<commit_message>
Write the contact address plainly, not as (at)
The obfuscated form was defending against address scrapers, but the mailto
href carried the real address anyway, so it bought nothing and cost every
reader a moment's decoding. Page footer, deck title slide and deck closing
slide, plus a rebuilt PDF.

Co-Authored-By: Claude Opus 5 (1M context) <noreply@anthropic.com>
</commit_message>
<xml_diff>
--- a/SruthiScribe-pitch.pptx
+++ b/SruthiScribe-pitch.pptx
@@ -3300,7 +3300,7 @@
                 </a:solidFill>
                 <a:latin typeface="Menlo"/>
               </a:rPr>
-              <a:t>Vinoth Kannan  ·  vinoth.kannan.eu(at)gmail.com</a:t>
+              <a:t>Vinoth Kannan  ·  vinoth.kannan.eu@gmail.com</a:t>
             </a:r>
           </a:p>
           <a:p>
@@ -3594,7 +3594,7 @@
                 </a:solidFill>
                 <a:latin typeface="Menlo"/>
               </a:rPr>
-              <a:t>Questions, corrections, missing compositions — Vinoth Kannan, vinoth.kannan.eu(at)gmail.com</a:t>
+              <a:t>Questions, corrections, missing compositions — Vinoth Kannan, vinoth.kannan.eu@gmail.com</a:t>
             </a:r>
           </a:p>
         </p:txBody>

</xml_diff>

<commit_message>
Deck limitations slide: carry the current measured figures (32% FA, 15% top-1)
Co-Authored-By: Claude Opus 5 (1M context) <noreply@anthropic.com>
</commit_message>
<xml_diff>
--- a/SruthiScribe-pitch.pptx
+++ b/SruthiScribe-pitch.pptx
@@ -8257,7 +8257,7 @@
                 </a:solidFill>
                 <a:latin typeface="Helvetica Neue"/>
               </a:rPr>
-              <a:t>Ragam identification is weak — 12% top-1</a:t>
+              <a:t>Ragam identification is weak — 15% top-1</a:t>
             </a:r>
           </a:p>
         </p:txBody>
@@ -8413,7 +8413,7 @@
                 </a:solidFill>
                 <a:latin typeface="Helvetica Neue"/>
               </a:rPr>
-              <a:t>Voicing false alarm is 35%</a:t>
+              <a:t>Voicing false alarm is 32%</a:t>
             </a:r>
           </a:p>
         </p:txBody>

</xml_diff>

<commit_message>
Deck brought current: 91.7%, retold honesty panel, abstention as a stated limit
The accuracy slide's honesty panel still described the harness as it stood
three engine generations ago (one dataset, one holdout, three excluded
records). It now tells the current story: every change must improve Sanidha
AND Saraga, both holdout halves, and survive a mis-set tonic; annotation
faults are excluded or repaired by rules that read only the reference; and
the page's published figures are tied to the measurement by a test. The
declined-frames figure joins the slide and the limitations slide as its own
card -- abstention is part of how the number is earned, so the deck says so.
Ragams wired into the decoder 114 -> 120; engine size 44 -> 46 kB; Sanidha
credited with its licence.

Co-Authored-By: Claude Opus 5 (1M context) <noreply@anthropic.com>
</commit_message>
<xml_diff>
--- a/SruthiScribe-pitch.pptx
+++ b/SruthiScribe-pitch.pptx
@@ -5148,7 +5148,7 @@
                 </a:solidFill>
                 <a:latin typeface="Helvetica Neue"/>
               </a:rPr>
-              <a:t>All 72 melakartas and their janyas, with arohana/avarohana; 114 wired into the decoder as constraints.</a:t>
+              <a:t>All 72 melakartas and their janyas, with arohana/avarohana; 120 wired into the decoder as constraints.</a:t>
             </a:r>
           </a:p>
         </p:txBody>
@@ -6443,7 +6443,7 @@
                 </a:solidFill>
                 <a:latin typeface="Helvetica Neue"/>
               </a:rPr>
-              <a:t>The engine is 44 kB of dependency-free JavaScript. Transcription works offline; nothing is uploaded.</a:t>
+              <a:t>The engine is 46 kB of dependency-free JavaScript. Transcription works offline; nothing is uploaded.</a:t>
             </a:r>
           </a:p>
         </p:txBody>
@@ -7325,7 +7325,7 @@
                 </a:solidFill>
                 <a:latin typeface="Helvetica Neue"/>
               </a:rPr>
-              <a:t>Scored on 33 items of Sanidha (Georgia Tech), studio multitrack, against the dataset's own pitch annotations.</a:t>
+              <a:t>Scored on 33 items of Sanidha (Georgia Tech, CC BY 4.0), studio multitrack, against the dataset's own pitch annotations. It declines 27% of sung frames rather than guess them.</a:t>
             </a:r>
           </a:p>
         </p:txBody>
@@ -7339,7 +7339,7 @@
         <p:spPr>
           <a:xfrm>
             <a:off x="822960" y="3977639"/>
-            <a:ext cx="10515600" cy="1417320"/>
+            <a:ext cx="10515600" cy="1645920"/>
           </a:xfrm>
           <a:prstGeom prst="roundRect">
             <a:avLst>
@@ -7387,7 +7387,7 @@
         <p:spPr>
           <a:xfrm>
             <a:off x="1143000" y="4206240"/>
-            <a:ext cx="9875520" cy="1371600"/>
+            <a:ext cx="9875520" cy="1554480"/>
           </a:xfrm>
           <a:prstGeom prst="rect">
             <a:avLst/>
@@ -7428,7 +7428,7 @@
                 </a:solidFill>
                 <a:latin typeface="Helvetica Neue"/>
               </a:rPr>
-              <a:t>The harness runs the engine that ships, not a copy. Records whose published annotation disagrees with their own audio are detected and excluded rather than averaged in — three of Sanidha's are annotated an octave high. Every engine change is confirmed on a held-out split before it lands.</a:t>
+              <a:t>The harness runs the engine that ships, not a copy. Every change must improve two datasets (Sanidha and Saraga), both halves of a holdout split, and survive a deliberately mis-set tonic before it lands — what helps one corpus and hurts the other is rejected. Annotation faults are handled in the open: three records whose contour tracks another instrument are excluded, and frames the dataset itself doubled an octave are repaired by rules that read only the reference, never the engine's output. The web page publishes these same figures, and a test fails if they drift from the measurement.</a:t>
             </a:r>
           </a:p>
         </p:txBody>
@@ -8413,7 +8413,7 @@
                 </a:solidFill>
                 <a:latin typeface="Helvetica Neue"/>
               </a:rPr>
-              <a:t>Voicing false alarm is 32%</a:t>
+              <a:t>It abstains, and it false-alarms</a:t>
             </a:r>
           </a:p>
         </p:txBody>
@@ -8452,7 +8452,7 @@
                 </a:solidFill>
                 <a:latin typeface="Helvetica Neue"/>
               </a:rPr>
-              <a:t>It still calls notes in the gaps. The weakest number in the engine, and known.</a:t>
+              <a:t>27% of sung frames get no svara — declined, not guessed — and 32% of silences still get called a note.</a:t>
             </a:r>
           </a:p>
         </p:txBody>

</xml_diff>

<commit_message>
Deck: Sadhana makes it a loop, not two halves
The need slide becomes three panels -- hear yourself, find it written,
practise against it -- because the product now closes: a student can sing a
kriti they cannot yet write, contribute it, and be drilled on the thing they
just wrote. Functionality gains a practice bullet. The landscape slide says
plainly that practice apps got there first and Sadhana is our answer to them;
what none of them close is the loop, and the SSP corpus is what makes closing
it worth anything. Panels grown and footnotes moved so the fifth item fits.

Co-Authored-By: Claude Opus 5 (1M context) <noreply@anthropic.com>
</commit_message>
<xml_diff>
--- a/SruthiScribe-pitch.pptx
+++ b/SruthiScribe-pitch.pptx
@@ -4281,7 +4281,7 @@
         <p:spPr>
           <a:xfrm>
             <a:off x="822960" y="1737360"/>
-            <a:ext cx="3328416" cy="2468880"/>
+            <a:ext cx="3328416" cy="2148840"/>
           </a:xfrm>
           <a:prstGeom prst="roundRect">
             <a:avLst>
@@ -4329,7 +4329,7 @@
         <p:spPr>
           <a:xfrm>
             <a:off x="1097280" y="2011680"/>
-            <a:ext cx="2779776" cy="2103120"/>
+            <a:ext cx="2779776" cy="1828800"/>
           </a:xfrm>
           <a:prstGeom prst="rect">
             <a:avLst/>
@@ -4400,7 +4400,7 @@
         <p:spPr>
           <a:xfrm>
             <a:off x="4425696" y="1737360"/>
-            <a:ext cx="3328416" cy="2468880"/>
+            <a:ext cx="3328416" cy="2148840"/>
           </a:xfrm>
           <a:prstGeom prst="roundRect">
             <a:avLst>
@@ -4448,7 +4448,7 @@
         <p:spPr>
           <a:xfrm>
             <a:off x="4700016" y="2011680"/>
-            <a:ext cx="2779776" cy="2103120"/>
+            <a:ext cx="2779776" cy="1828800"/>
           </a:xfrm>
           <a:prstGeom prst="rect">
             <a:avLst/>
@@ -4519,7 +4519,7 @@
         <p:spPr>
           <a:xfrm>
             <a:off x="8028431" y="1737360"/>
-            <a:ext cx="3328416" cy="2468880"/>
+            <a:ext cx="3328416" cy="2148840"/>
           </a:xfrm>
           <a:prstGeom prst="roundRect">
             <a:avLst>
@@ -4567,7 +4567,7 @@
         <p:spPr>
           <a:xfrm>
             <a:off x="8302752" y="2011680"/>
-            <a:ext cx="2779776" cy="2103120"/>
+            <a:ext cx="2779776" cy="1828800"/>
           </a:xfrm>
           <a:prstGeom prst="rect">
             <a:avLst/>
@@ -4637,8 +4637,8 @@
         </p:nvSpPr>
         <p:spPr>
           <a:xfrm>
-            <a:off x="822960" y="4526280"/>
-            <a:ext cx="10515600" cy="731520"/>
+            <a:off x="822960" y="4206240"/>
+            <a:ext cx="10515600" cy="822960"/>
           </a:xfrm>
           <a:prstGeom prst="rect">
             <a:avLst/>
@@ -9047,7 +9047,7 @@
         <p:spPr>
           <a:xfrm>
             <a:off x="822960" y="1691640"/>
-            <a:ext cx="5120640" cy="3291840"/>
+            <a:ext cx="5120640" cy="3794760"/>
           </a:xfrm>
           <a:prstGeom prst="roundRect">
             <a:avLst>
@@ -9095,7 +9095,7 @@
         <p:spPr>
           <a:xfrm>
             <a:off x="1143000" y="1965960"/>
-            <a:ext cx="4480560" cy="2926080"/>
+            <a:ext cx="4480560" cy="3429000"/>
           </a:xfrm>
           <a:prstGeom prst="rect">
             <a:avLst/>
@@ -9294,7 +9294,7 @@
         <p:spPr>
           <a:xfrm>
             <a:off x="6309360" y="1691640"/>
-            <a:ext cx="5029200" cy="3291840"/>
+            <a:ext cx="5029200" cy="3794760"/>
           </a:xfrm>
           <a:prstGeom prst="roundRect">
             <a:avLst>
@@ -9342,7 +9342,7 @@
         <p:spPr>
           <a:xfrm>
             <a:off x="6629400" y="1965960"/>
-            <a:ext cx="4389120" cy="2926080"/>
+            <a:ext cx="4389120" cy="3429000"/>
           </a:xfrm>
           <a:prstGeom prst="rect">
             <a:avLst/>
@@ -9540,8 +9540,8 @@
         </p:nvSpPr>
         <p:spPr>
           <a:xfrm>
-            <a:off x="822960" y="5193792"/>
-            <a:ext cx="10515600" cy="731520"/>
+            <a:off x="822960" y="5650992"/>
+            <a:ext cx="10515600" cy="822960"/>
           </a:xfrm>
           <a:prstGeom prst="rect">
             <a:avLst/>

</xml_diff>